<commit_message>
docs: bloque1 profundiza detección de comunidades Louvain, caso CardingForums referencia bloque1
Bloque1 (demo_bigdata.ipynb) añade sección de Louvain/modularidad con
comentarios didácticos línea a línea y regenera las diapositivas.
02_analisis_estructural.ipynb recorta las explicaciones ya cubiertas
en bloque1 y las sustituye por preguntas de análisis específicas del
mercado de CardingForums.
</commit_message>
<xml_diff>
--- a/bloque1_bigdata/csbc26_b1_bigdata.pptx
+++ b/bloque1_bigdata/csbc26_b1_bigdata.pptx
@@ -822,6 +822,11 @@
               <a:t>→ spikes: z-score, umbral µ+2σ</a:t>
             </a:r>
           </a:p>
+          <a:p>
+            <a:r>
+              <a:t>→ forward-ref: el mismo patrón semanal profesional reaparece en Ransomware como señal de operación profesionalizada</a:t>
+            </a:r>
+          </a:p>
         </p:txBody>
       </p:sp>
       <p:sp>
@@ -894,7 +899,7 @@
           </a:p>
           <a:p>
             <a:r>
-              <a:t>TF-IDF: términos discriminantes por foro/periodo</a:t>
+              <a:t>TF-IDF = Term Frequency–Inverse Document Frequency: términos discriminantes por foro/periodo</a:t>
             </a:r>
           </a:p>
           <a:p>
@@ -904,7 +909,7 @@
           </a:p>
           <a:p>
             <a:r>
-              <a:t>Funciona bien con texto ruidoso/slang</a:t>
+              <a:t>Funciona bien con texto ruidoso/jerga (ya vista en D3)</a:t>
             </a:r>
           </a:p>
           <a:p>
@@ -1064,12 +1069,12 @@
           <a:lstStyle/>
           <a:p>
             <a:r>
-              <a:t>Parte práctica — notebook CardingForums</a:t>
-            </a:r>
-          </a:p>
-          <a:p>
-            <a:r>
-              <a:t>Cargar dataset, auto-detección formato</a:t>
+              <a:t>Parte práctica — notebook demo_bigdata.ipynb (dataset CardingForums)</a:t>
+            </a:r>
+          </a:p>
+          <a:p>
+            <a:r>
+              <a:t>Cargar datos ya limpios (parquet), sin volver a parsear</a:t>
             </a:r>
           </a:p>
           <a:p>
@@ -1159,7 +1164,7 @@
           </a:p>
           <a:p>
             <a:r>
-              <a:t>Ojo: no es Hadoop ni petabytes</a:t>
+              <a:t>Ojo: no es cómputo distribuido a gran escala ni petabytes</a:t>
             </a:r>
           </a:p>
           <a:p>
@@ -1239,7 +1244,7 @@
           <a:lstStyle/>
           <a:p>
             <a:r>
-              <a:t>Expectativa clara: nada de cluster Hadoop</a:t>
+              <a:t>Expectativa clara: nada de cluster distribuido a gran escala</a:t>
             </a:r>
           </a:p>
           <a:p>
@@ -1249,7 +1254,7 @@
           </a:p>
           <a:p>
             <a:r>
-              <a:t>Power-law casi universal: 1% usuarios, 80% contenido</a:t>
+              <a:t>Explorar la forma primero: power-law es un ejemplo, no un dato aislado (1% usuarios, 80% contenido)</a:t>
             </a:r>
           </a:p>
           <a:p>
@@ -1514,7 +1519,12 @@
           </a:p>
           <a:p>
             <a:r>
-              <a:t>Louvain: comunidades sin fijar K</a:t>
+              <a:t>Louvain: maximiza modularidad, sin fijar K, fusiones locales iterativas hasta converger</a:t>
+            </a:r>
+          </a:p>
+          <a:p>
+            <a:r>
+              <a:t>→ speaker note: mostrar animación Louvain en vivo (fuente externa) si hay tiempo, no GIF embebido</a:t>
             </a:r>
           </a:p>
           <a:p>
@@ -1599,7 +1609,7 @@
           </a:p>
           <a:p>
             <a:r>
-              <a:t>Privada: rara en leaks, oro puro, confianza real</a:t>
+              <a:t>Privada: no universal, pero varios leaks del curso sí la incluyen — oro puro, confianza real</a:t>
             </a:r>
           </a:p>
           <a:p>
@@ -1674,7 +1684,7 @@
           <a:lstStyle/>
           <a:p>
             <a:r>
-              <a:t>Análisis más potente del bloque</a:t>
+              <a:t>Primer paso rápido, no la técnica más potente del bloque</a:t>
             </a:r>
           </a:p>
           <a:p>
@@ -1694,7 +1704,7 @@
           </a:p>
           <a:p>
             <a:r>
-              <a:t>→ base de investigación cross-foro</a:t>
+              <a:t>→ complementario a estilometría (Burrows' Delta) en HackingForums, no la reemplaza</a:t>
             </a:r>
           </a:p>
         </p:txBody>
@@ -5476,8 +5486,8 @@
         </p:nvSpPr>
         <p:spPr>
           <a:xfrm>
-            <a:off x="1073427" y="2077576"/>
-            <a:ext cx="10084904" cy="3507298"/>
+            <a:off x="1073427" y="2214736"/>
+            <a:ext cx="10084904" cy="3370138"/>
           </a:xfrm>
         </p:spPr>
         <p:txBody>
@@ -5566,8 +5576,8 @@
         </p:nvSpPr>
         <p:spPr>
           <a:xfrm>
-            <a:off x="1073427" y="2077576"/>
-            <a:ext cx="10084904" cy="3507298"/>
+            <a:off x="1073427" y="2214736"/>
+            <a:ext cx="10084904" cy="3370138"/>
           </a:xfrm>
         </p:spPr>
         <p:txBody>
@@ -5575,7 +5585,7 @@
           <a:lstStyle/>
           <a:p>
             <a:r>
-              <a:t>TF-IDF: términos más discriminantes por foro, por período, por subgrupo</a:t>
+              <a:t>TF-IDF (Term Frequency – Inverse Document Frequency): términos más discriminantes por foro, período o subgrupo</a:t>
             </a:r>
           </a:p>
           <a:p>
@@ -5590,7 +5600,7 @@
           </a:p>
           <a:p>
             <a:r>
-              <a:t>Funciona bien incluso con texto ruidoso, slang y abreviaciones</a:t>
+              <a:t>Funciona bien incluso con texto ruidoso, jerga (ya vista) y abreviaciones</a:t>
             </a:r>
           </a:p>
           <a:p>
@@ -5670,7 +5680,7 @@
           <p:nvPr/>
         </p:nvGraphicFramePr>
         <p:xfrm>
-          <a:off x="1051560" y="2651760"/>
+          <a:off x="1051560" y="2788920"/>
           <a:ext cx="10058400" cy="1828800"/>
         </p:xfrm>
         <a:graphic>
@@ -6174,7 +6184,7 @@
           <a:p>
             <a:pPr algn="ctr"/>
             <a:r>
-              <a:rPr sz="1300" b="1">
+              <a:rPr sz="1700" b="1">
                 <a:solidFill>
                   <a:srgbClr val="CD2D37"/>
                 </a:solidFill>
@@ -6198,7 +6208,7 @@
                 </a:solidFill>
                 <a:latin typeface="Arial"/>
               </a:rPr>
-              <a:t>CardingForums/01_carding_forums.ipynb</a:t>
+              <a:t>bloque1_bigdata/demo_bigdata.ipynb</a:t>
             </a:r>
           </a:p>
         </p:txBody>
@@ -6232,7 +6242,7 @@
                 </a:solidFill>
                 <a:latin typeface="Arial"/>
               </a:rPr>
-              <a:t>1.  Cargar dataset con load_forum() — auto-detección de formato</a:t>
+              <a:t>1.  Cargar datos ya limpios con pd.read_parquet() — sin volver a parsear</a:t>
             </a:r>
           </a:p>
           <a:p>
@@ -6316,7 +6326,7 @@
           <a:p>
             <a:pPr algn="ctr"/>
             <a:r>
-              <a:rPr sz="1300" b="1">
+              <a:rPr sz="1700" b="1">
                 <a:solidFill>
                   <a:srgbClr val="CD2D37"/>
                 </a:solidFill>
@@ -6396,8 +6406,8 @@
         </p:nvSpPr>
         <p:spPr>
           <a:xfrm>
-            <a:off x="1073427" y="2077576"/>
-            <a:ext cx="10084904" cy="3507298"/>
+            <a:off x="1073427" y="2214736"/>
+            <a:ext cx="10084904" cy="3370138"/>
           </a:xfrm>
         </p:spPr>
         <p:txBody>
@@ -6405,22 +6415,22 @@
           <a:lstStyle/>
           <a:p>
             <a:r>
-              <a:t>No estamos en Hadoop: millones de registros, no billones</a:t>
-            </a:r>
-          </a:p>
-          <a:p>
-            <a:r>
-              <a:t>El problema real: datos sucios, schemas inconsistentes, duplicados, texto multilingüe</a:t>
-            </a:r>
-          </a:p>
-          <a:p>
-            <a:r>
-              <a:t>Primero explorar, luego analizar — no al revés</a:t>
-            </a:r>
-          </a:p>
-          <a:p>
-            <a:r>
-              <a:t>La curva power-law es universal en foros: el 1% de usuarios genera el 80% del contenido</a:t>
+              <a:t>No es un cluster distribuido a gran escala: millones de registros, no billones</a:t>
+            </a:r>
+          </a:p>
+          <a:p>
+            <a:r>
+              <a:t>El problema real: datos sucios, schemas inconsistentes, duplicados, texto multilingüe (slang, leetspeak)</a:t>
+            </a:r>
+          </a:p>
+          <a:p>
+            <a:r>
+              <a:t>Primero explorar, luego analizar — entender la forma del dataset antes de medirlo</a:t>
+            </a:r>
+          </a:p>
+          <a:p>
+            <a:r>
+              <a:t>Ejemplo de esa forma: la curva power-law es universal en foros — el 1% de usuarios genera el 80% del contenido</a:t>
             </a:r>
           </a:p>
           <a:p>
@@ -6486,8 +6496,8 @@
         </p:nvSpPr>
         <p:spPr>
           <a:xfrm>
-            <a:off x="1073427" y="2580496"/>
-            <a:ext cx="10084904" cy="3004378"/>
+            <a:off x="1073427" y="2717656"/>
+            <a:ext cx="10084904" cy="2867218"/>
           </a:xfrm>
         </p:spPr>
         <p:txBody>
@@ -6560,7 +6570,7 @@
           <a:p>
             <a:pPr algn="ctr"/>
             <a:r>
-              <a:rPr sz="1300" b="1">
+              <a:rPr sz="1700" b="1">
                 <a:solidFill>
                   <a:srgbClr val="CD2D37"/>
                 </a:solidFill>
@@ -6584,7 +6594,7 @@
                 </a:solidFill>
                 <a:latin typeface="Arial"/>
               </a:rPr>
-              <a:t>Los foros son grafos — úsalos como tales</a:t>
+              <a:t>Grafos: la técnica estructural central de este bloque</a:t>
             </a:r>
           </a:p>
         </p:txBody>
@@ -6640,8 +6650,8 @@
         </p:nvSpPr>
         <p:spPr>
           <a:xfrm>
-            <a:off x="1073427" y="2077576"/>
-            <a:ext cx="10084904" cy="3507298"/>
+            <a:off x="1073427" y="2214736"/>
+            <a:ext cx="10084904" cy="3370138"/>
           </a:xfrm>
         </p:spPr>
         <p:txBody>
@@ -6664,7 +6674,7 @@
           </a:p>
           <a:p>
             <a:r>
-              <a:t>Algoritmos de detección de comunidades: Louvain sin necesidad de especificar K</a:t>
+              <a:t>Louvain: agrupa nodos maximizando modularidad, sin fijar K, por fusiones locales iterativas</a:t>
             </a:r>
           </a:p>
           <a:p>
@@ -6743,7 +6753,7 @@
         </p:nvSpPr>
         <p:spPr>
           <a:xfrm>
-            <a:off x="1051560" y="2194560"/>
+            <a:off x="1051560" y="2331720"/>
             <a:ext cx="4846320" cy="411480"/>
           </a:xfrm>
           <a:prstGeom prst="rect">
@@ -6778,8 +6788,8 @@
         </p:nvSpPr>
         <p:spPr>
           <a:xfrm>
-            <a:off x="1051560" y="2651760"/>
-            <a:ext cx="4846320" cy="3337560"/>
+            <a:off x="1051560" y="2788920"/>
+            <a:ext cx="4846320" cy="3200400"/>
           </a:xfrm>
           <a:prstGeom prst="rect">
             <a:avLst/>
@@ -6795,14 +6805,12 @@
             <a:r>
               <a:rPr sz="1600">
                 <a:solidFill>
-                  <a:srgbClr val="465461"/>
+                  <a:srgbClr val="CD2D37"/>
                 </a:solidFill>
                 <a:latin typeface="Arial"/>
               </a:rPr>
-              <a:t>▸  Aristas visibles a todos los miembros</a:t>
-            </a:r>
-          </a:p>
-          <a:p>
+              <a:t>▸  </a:t>
+            </a:r>
             <a:r>
               <a:rPr sz="1600">
                 <a:solidFill>
@@ -6810,10 +6818,19 @@
                 </a:solidFill>
                 <a:latin typeface="Arial"/>
               </a:rPr>
-              <a:t>▸  Refleja influencia pública y reputación</a:t>
-            </a:r>
-          </a:p>
-          <a:p>
+              <a:t>Conexiones visibles a todos los miembros del foro</a:t>
+            </a:r>
+          </a:p>
+          <a:p>
+            <a:r>
+              <a:rPr sz="1600">
+                <a:solidFill>
+                  <a:srgbClr val="CD2D37"/>
+                </a:solidFill>
+                <a:latin typeface="Arial"/>
+              </a:rPr>
+              <a:t>▸  </a:t>
+            </a:r>
             <a:r>
               <a:rPr sz="1600">
                 <a:solidFill>
@@ -6821,10 +6838,19 @@
                 </a:solidFill>
                 <a:latin typeface="Arial"/>
               </a:rPr>
-              <a:t>▸  Broker: el usuario más citado/respondido</a:t>
-            </a:r>
-          </a:p>
-          <a:p>
+              <a:t>Refleja influencia pública y reputación</a:t>
+            </a:r>
+          </a:p>
+          <a:p>
+            <a:r>
+              <a:rPr sz="1600">
+                <a:solidFill>
+                  <a:srgbClr val="CD2D37"/>
+                </a:solidFill>
+                <a:latin typeface="Arial"/>
+              </a:rPr>
+              <a:t>▸  </a:t>
+            </a:r>
             <a:r>
               <a:rPr sz="1600">
                 <a:solidFill>
@@ -6832,7 +6858,27 @@
                 </a:solidFill>
                 <a:latin typeface="Arial"/>
               </a:rPr>
-              <a:t>▸  Sesgada hacia los usuarios más activos</a:t>
+              <a:t>Broker: el usuario más citado/respondido</a:t>
+            </a:r>
+          </a:p>
+          <a:p>
+            <a:r>
+              <a:rPr sz="1600">
+                <a:solidFill>
+                  <a:srgbClr val="CD2D37"/>
+                </a:solidFill>
+                <a:latin typeface="Arial"/>
+              </a:rPr>
+              <a:t>▸  </a:t>
+            </a:r>
+            <a:r>
+              <a:rPr sz="1600">
+                <a:solidFill>
+                  <a:srgbClr val="465461"/>
+                </a:solidFill>
+                <a:latin typeface="Arial"/>
+              </a:rPr>
+              <a:t>Sesgada hacia los usuarios más activos</a:t>
             </a:r>
           </a:p>
         </p:txBody>
@@ -6845,7 +6891,7 @@
         </p:nvSpPr>
         <p:spPr>
           <a:xfrm>
-            <a:off x="6217920" y="2194560"/>
+            <a:off x="6217920" y="2331720"/>
             <a:ext cx="4846320" cy="411480"/>
           </a:xfrm>
           <a:prstGeom prst="rect">
@@ -6880,8 +6926,8 @@
         </p:nvSpPr>
         <p:spPr>
           <a:xfrm>
-            <a:off x="6217920" y="2651760"/>
-            <a:ext cx="4846320" cy="3337560"/>
+            <a:off x="6217920" y="2788920"/>
+            <a:ext cx="4846320" cy="3200400"/>
           </a:xfrm>
           <a:prstGeom prst="rect">
             <a:avLst/>
@@ -6897,14 +6943,12 @@
             <a:r>
               <a:rPr sz="1600">
                 <a:solidFill>
-                  <a:srgbClr val="465461"/>
+                  <a:srgbClr val="CD2D37"/>
                 </a:solidFill>
                 <a:latin typeface="Arial"/>
               </a:rPr>
-              <a:t>▸  Aristas ocultas — datos rarísimos en leaks</a:t>
-            </a:r>
-          </a:p>
-          <a:p>
+              <a:t>▸  </a:t>
+            </a:r>
             <a:r>
               <a:rPr sz="1600">
                 <a:solidFill>
@@ -6912,10 +6956,19 @@
                 </a:solidFill>
                 <a:latin typeface="Arial"/>
               </a:rPr>
-              <a:t>▸  Refleja confianza real entre actores</a:t>
-            </a:r>
-          </a:p>
-          <a:p>
+              <a:t>Conexiones no visibles — solo aparece si el leak los incluye</a:t>
+            </a:r>
+          </a:p>
+          <a:p>
+            <a:r>
+              <a:rPr sz="1600">
+                <a:solidFill>
+                  <a:srgbClr val="CD2D37"/>
+                </a:solidFill>
+                <a:latin typeface="Arial"/>
+              </a:rPr>
+              <a:t>▸  </a:t>
+            </a:r>
             <a:r>
               <a:rPr sz="1600">
                 <a:solidFill>
@@ -6923,10 +6976,19 @@
                 </a:solidFill>
                 <a:latin typeface="Arial"/>
               </a:rPr>
-              <a:t>▸  Broker privado ≠ broker público (casi siempre)</a:t>
-            </a:r>
-          </a:p>
-          <a:p>
+              <a:t>Refleja confianza real entre actores</a:t>
+            </a:r>
+          </a:p>
+          <a:p>
+            <a:r>
+              <a:rPr sz="1600">
+                <a:solidFill>
+                  <a:srgbClr val="CD2D37"/>
+                </a:solidFill>
+                <a:latin typeface="Arial"/>
+              </a:rPr>
+              <a:t>▸  </a:t>
+            </a:r>
             <a:r>
               <a:rPr sz="1600">
                 <a:solidFill>
@@ -6934,7 +6996,27 @@
                 </a:solidFill>
                 <a:latin typeface="Arial"/>
               </a:rPr>
-              <a:t>▸  Cuando está disponible, es el dato más valioso</a:t>
+              <a:t>Broker privado ≠ broker público (casi siempre)</a:t>
+            </a:r>
+          </a:p>
+          <a:p>
+            <a:r>
+              <a:rPr sz="1600">
+                <a:solidFill>
+                  <a:srgbClr val="CD2D37"/>
+                </a:solidFill>
+                <a:latin typeface="Arial"/>
+              </a:rPr>
+              <a:t>▸  </a:t>
+            </a:r>
+            <a:r>
+              <a:rPr sz="1600">
+                <a:solidFill>
+                  <a:srgbClr val="465461"/>
+                </a:solidFill>
+                <a:latin typeface="Arial"/>
+              </a:rPr>
+              <a:t>Cuando está disponible, es el dato más valioso</a:t>
             </a:r>
           </a:p>
         </p:txBody>
@@ -6973,7 +7055,7 @@
           <a:lstStyle/>
           <a:p>
             <a:r>
-              <a:t>Pivoting de identidades — el análisis más potente</a:t>
+              <a:t>Pivoting de identidades — primer paso, complementario a la estilometría</a:t>
             </a:r>
           </a:p>
         </p:txBody>
@@ -6990,8 +7072,8 @@
         </p:nvSpPr>
         <p:spPr>
           <a:xfrm>
-            <a:off x="1073427" y="2077576"/>
-            <a:ext cx="10084904" cy="3507298"/>
+            <a:off x="1073427" y="3220576"/>
+            <a:ext cx="10084904" cy="2364298"/>
           </a:xfrm>
         </p:spPr>
         <p:txBody>
@@ -7024,7 +7106,7 @@
           </a:p>
           <a:p>
             <a:r>
-              <a:t>Esto es pivoting manual — la base de cualquier investigación cross-foro</a:t>
+              <a:t>Pivoting manual, rápido y preparatorio — la confirmación fuerte llega con estilometría (Burrows' Delta, caso HackingForums)</a:t>
             </a:r>
           </a:p>
         </p:txBody>
@@ -7064,7 +7146,7 @@
           <a:p>
             <a:pPr algn="ctr"/>
             <a:r>
-              <a:rPr sz="1300" b="1">
+              <a:rPr sz="1700" b="1">
                 <a:solidFill>
                   <a:srgbClr val="CD2D37"/>
                 </a:solidFill>

</xml_diff>